<commit_message>
LATE: Behebung der Fehler in der Pipeline, hinzufügen eines weiteren thresholdtests
</commit_message>
<xml_diff>
--- a/ProjektPräsentation.pptx
+++ b/ProjektPräsentation.pptx
@@ -14,6 +14,9 @@
     <p:sldId id="262" r:id="rId8"/>
     <p:sldId id="263" r:id="rId9"/>
     <p:sldId id="264" r:id="rId10"/>
+    <p:sldId id="265" r:id="rId11"/>
+    <p:sldId id="266" r:id="rId12"/>
+    <p:sldId id="267" r:id="rId13"/>
   </p:sldIdLst>
   <p:sldSz cx="12192000" cy="6858000"/>
   <p:notesSz cx="6858000" cy="9144000"/>
@@ -112,7 +115,142 @@
       </a:defRPr>
     </a:lvl9pPr>
   </p:defaultTextStyle>
+  <p:extLst>
+    <p:ext uri="{EFAFB233-063F-42B5-8137-9DF3F51BA10A}">
+      <p15:sldGuideLst xmlns:p15="http://schemas.microsoft.com/office/powerpoint/2012/main"/>
+    </p:ext>
+  </p:extLst>
 </p:presentation>
+</file>
+
+<file path=ppt/revisionInfo.xml><?xml version="1.0" encoding="utf-8"?>
+<p1510:revInfo xmlns:a="http://schemas.openxmlformats.org/drawingml/2006/main" xmlns:r="http://schemas.openxmlformats.org/officeDocument/2006/relationships" xmlns:p1510="http://schemas.microsoft.com/office/powerpoint/2015/10/main">
+  <p1510:revLst>
+    <p1510:client id="{0737C12F-E4EA-4569-92FF-D80EAF3464AC}" v="1" dt="2026-06-27T06:28:16.033"/>
+  </p1510:revLst>
+</p1510:revInfo>
+</file>
+
+<file path=ppt/changesInfos/changesInfo1.xml><?xml version="1.0" encoding="utf-8"?>
+<pc:chgInfo xmlns:a="http://schemas.openxmlformats.org/drawingml/2006/main" xmlns:r="http://schemas.openxmlformats.org/officeDocument/2006/relationships" xmlns:ac="http://schemas.microsoft.com/office/drawing/2013/main/command" xmlns:pc="http://schemas.microsoft.com/office/powerpoint/2013/main/command">
+  <pc:docChgLst>
+    <pc:chgData name="Daniel Brandstätter" userId="5b1b139165ee62c7" providerId="LiveId" clId="{D840519E-19CB-4CC0-A570-1357A189EF63}"/>
+    <pc:docChg chg="undo custSel addSld modSld">
+      <pc:chgData name="Daniel Brandstätter" userId="5b1b139165ee62c7" providerId="LiveId" clId="{D840519E-19CB-4CC0-A570-1357A189EF63}" dt="2026-06-27T06:30:11.767" v="436" actId="20577"/>
+      <pc:docMkLst>
+        <pc:docMk/>
+      </pc:docMkLst>
+      <pc:sldChg chg="modSp mod">
+        <pc:chgData name="Daniel Brandstätter" userId="5b1b139165ee62c7" providerId="LiveId" clId="{D840519E-19CB-4CC0-A570-1357A189EF63}" dt="2026-06-27T06:20:33.971" v="106" actId="20577"/>
+        <pc:sldMkLst>
+          <pc:docMk/>
+          <pc:sldMk cId="2682684029" sldId="262"/>
+        </pc:sldMkLst>
+        <pc:spChg chg="mod">
+          <ac:chgData name="Daniel Brandstätter" userId="5b1b139165ee62c7" providerId="LiveId" clId="{D840519E-19CB-4CC0-A570-1357A189EF63}" dt="2026-06-27T06:20:33.971" v="106" actId="20577"/>
+          <ac:spMkLst>
+            <pc:docMk/>
+            <pc:sldMk cId="2682684029" sldId="262"/>
+            <ac:spMk id="3" creationId="{52B3CED9-C21A-1500-7848-5B0523E73FE7}"/>
+          </ac:spMkLst>
+        </pc:spChg>
+      </pc:sldChg>
+      <pc:sldChg chg="modSp new mod">
+        <pc:chgData name="Daniel Brandstätter" userId="5b1b139165ee62c7" providerId="LiveId" clId="{D840519E-19CB-4CC0-A570-1357A189EF63}" dt="2026-06-27T06:26:50.206" v="366" actId="20577"/>
+        <pc:sldMkLst>
+          <pc:docMk/>
+          <pc:sldMk cId="2569992703" sldId="265"/>
+        </pc:sldMkLst>
+        <pc:spChg chg="mod">
+          <ac:chgData name="Daniel Brandstätter" userId="5b1b139165ee62c7" providerId="LiveId" clId="{D840519E-19CB-4CC0-A570-1357A189EF63}" dt="2026-06-27T06:26:50.206" v="366" actId="20577"/>
+          <ac:spMkLst>
+            <pc:docMk/>
+            <pc:sldMk cId="2569992703" sldId="265"/>
+            <ac:spMk id="2" creationId="{822404E0-7640-7C59-DFAF-7ABB31DB7263}"/>
+          </ac:spMkLst>
+        </pc:spChg>
+        <pc:spChg chg="mod">
+          <ac:chgData name="Daniel Brandstätter" userId="5b1b139165ee62c7" providerId="LiveId" clId="{D840519E-19CB-4CC0-A570-1357A189EF63}" dt="2026-06-27T06:26:10.034" v="358" actId="20577"/>
+          <ac:spMkLst>
+            <pc:docMk/>
+            <pc:sldMk cId="2569992703" sldId="265"/>
+            <ac:spMk id="3" creationId="{A5B2834C-0DFD-BB04-4FA8-E04275CCEE40}"/>
+          </ac:spMkLst>
+        </pc:spChg>
+      </pc:sldChg>
+      <pc:sldChg chg="addSp modSp new mod">
+        <pc:chgData name="Daniel Brandstätter" userId="5b1b139165ee62c7" providerId="LiveId" clId="{D840519E-19CB-4CC0-A570-1357A189EF63}" dt="2026-06-27T06:30:01.012" v="416" actId="20577"/>
+        <pc:sldMkLst>
+          <pc:docMk/>
+          <pc:sldMk cId="1465121941" sldId="266"/>
+        </pc:sldMkLst>
+        <pc:spChg chg="mod">
+          <ac:chgData name="Daniel Brandstätter" userId="5b1b139165ee62c7" providerId="LiveId" clId="{D840519E-19CB-4CC0-A570-1357A189EF63}" dt="2026-06-27T06:30:01.012" v="416" actId="20577"/>
+          <ac:spMkLst>
+            <pc:docMk/>
+            <pc:sldMk cId="1465121941" sldId="266"/>
+            <ac:spMk id="2" creationId="{5F1A5C91-06C3-FB2C-2233-6C5D4CE2E350}"/>
+          </ac:spMkLst>
+        </pc:spChg>
+        <pc:picChg chg="add mod">
+          <ac:chgData name="Daniel Brandstätter" userId="5b1b139165ee62c7" providerId="LiveId" clId="{D840519E-19CB-4CC0-A570-1357A189EF63}" dt="2026-06-27T06:28:20.422" v="389" actId="1076"/>
+          <ac:picMkLst>
+            <pc:docMk/>
+            <pc:sldMk cId="1465121941" sldId="266"/>
+            <ac:picMk id="4" creationId="{A04F5B7D-BF20-EEE4-87F4-ABFAE324C4E5}"/>
+          </ac:picMkLst>
+        </pc:picChg>
+      </pc:sldChg>
+      <pc:sldChg chg="addSp delSp modSp add mod">
+        <pc:chgData name="Daniel Brandstätter" userId="5b1b139165ee62c7" providerId="LiveId" clId="{D840519E-19CB-4CC0-A570-1357A189EF63}" dt="2026-06-27T06:30:11.767" v="436" actId="20577"/>
+        <pc:sldMkLst>
+          <pc:docMk/>
+          <pc:sldMk cId="1055078836" sldId="267"/>
+        </pc:sldMkLst>
+        <pc:spChg chg="mod">
+          <ac:chgData name="Daniel Brandstätter" userId="5b1b139165ee62c7" providerId="LiveId" clId="{D840519E-19CB-4CC0-A570-1357A189EF63}" dt="2026-06-27T06:30:11.767" v="436" actId="20577"/>
+          <ac:spMkLst>
+            <pc:docMk/>
+            <pc:sldMk cId="1055078836" sldId="267"/>
+            <ac:spMk id="2" creationId="{73412F77-1982-D332-2CE1-681EE89D99D4}"/>
+          </ac:spMkLst>
+        </pc:spChg>
+        <pc:spChg chg="add del">
+          <ac:chgData name="Daniel Brandstätter" userId="5b1b139165ee62c7" providerId="LiveId" clId="{D840519E-19CB-4CC0-A570-1357A189EF63}" dt="2026-06-27T06:29:17.011" v="396"/>
+          <ac:spMkLst>
+            <pc:docMk/>
+            <pc:sldMk cId="1055078836" sldId="267"/>
+            <ac:spMk id="3" creationId="{5F997219-4D5D-3E3E-A49C-DABB6B92D29D}"/>
+          </ac:spMkLst>
+        </pc:spChg>
+        <pc:picChg chg="del">
+          <ac:chgData name="Daniel Brandstätter" userId="5b1b139165ee62c7" providerId="LiveId" clId="{D840519E-19CB-4CC0-A570-1357A189EF63}" dt="2026-06-27T06:28:43.251" v="391" actId="478"/>
+          <ac:picMkLst>
+            <pc:docMk/>
+            <pc:sldMk cId="1055078836" sldId="267"/>
+            <ac:picMk id="4" creationId="{A4B1CEA4-78A9-436A-AF8F-A28A7DD6EFD0}"/>
+          </ac:picMkLst>
+        </pc:picChg>
+        <pc:picChg chg="add del mod ord">
+          <ac:chgData name="Daniel Brandstätter" userId="5b1b139165ee62c7" providerId="LiveId" clId="{D840519E-19CB-4CC0-A570-1357A189EF63}" dt="2026-06-27T06:29:11.309" v="394" actId="931"/>
+          <ac:picMkLst>
+            <pc:docMk/>
+            <pc:sldMk cId="1055078836" sldId="267"/>
+            <ac:picMk id="6" creationId="{B93B147B-4FFD-D060-051D-121905434AAD}"/>
+          </ac:picMkLst>
+        </pc:picChg>
+        <pc:picChg chg="add mod ord">
+          <ac:chgData name="Daniel Brandstätter" userId="5b1b139165ee62c7" providerId="LiveId" clId="{D840519E-19CB-4CC0-A570-1357A189EF63}" dt="2026-06-27T06:29:46.616" v="402" actId="1076"/>
+          <ac:picMkLst>
+            <pc:docMk/>
+            <pc:sldMk cId="1055078836" sldId="267"/>
+            <ac:picMk id="8" creationId="{3B744437-88BB-0298-FB3B-86E85DCFE67C}"/>
+          </ac:picMkLst>
+        </pc:picChg>
+      </pc:sldChg>
+    </pc:docChg>
+  </pc:docChgLst>
+</pc:chgInfo>
 </file>
 
 <file path=ppt/diagrams/colors1.xml><?xml version="1.0" encoding="utf-8"?>
@@ -9156,7 +9294,7 @@
           <a:p>
             <a:fld id="{0A963F5A-521E-487D-BEA2-802DBD526383}" type="datetimeFigureOut">
               <a:rPr lang="de-AT" smtClean="0"/>
-              <a:t>26.06.2026</a:t>
+              <a:t>27.06.2026</a:t>
             </a:fld>
             <a:endParaRPr lang="de-AT"/>
           </a:p>
@@ -9356,7 +9494,7 @@
           <a:p>
             <a:fld id="{0A963F5A-521E-487D-BEA2-802DBD526383}" type="datetimeFigureOut">
               <a:rPr lang="de-AT" smtClean="0"/>
-              <a:t>26.06.2026</a:t>
+              <a:t>27.06.2026</a:t>
             </a:fld>
             <a:endParaRPr lang="de-AT"/>
           </a:p>
@@ -9566,7 +9704,7 @@
           <a:p>
             <a:fld id="{0A963F5A-521E-487D-BEA2-802DBD526383}" type="datetimeFigureOut">
               <a:rPr lang="de-AT" smtClean="0"/>
-              <a:t>26.06.2026</a:t>
+              <a:t>27.06.2026</a:t>
             </a:fld>
             <a:endParaRPr lang="de-AT"/>
           </a:p>
@@ -9766,7 +9904,7 @@
           <a:p>
             <a:fld id="{0A963F5A-521E-487D-BEA2-802DBD526383}" type="datetimeFigureOut">
               <a:rPr lang="de-AT" smtClean="0"/>
-              <a:t>26.06.2026</a:t>
+              <a:t>27.06.2026</a:t>
             </a:fld>
             <a:endParaRPr lang="de-AT"/>
           </a:p>
@@ -10042,7 +10180,7 @@
           <a:p>
             <a:fld id="{0A963F5A-521E-487D-BEA2-802DBD526383}" type="datetimeFigureOut">
               <a:rPr lang="de-AT" smtClean="0"/>
-              <a:t>26.06.2026</a:t>
+              <a:t>27.06.2026</a:t>
             </a:fld>
             <a:endParaRPr lang="de-AT"/>
           </a:p>
@@ -10310,7 +10448,7 @@
           <a:p>
             <a:fld id="{0A963F5A-521E-487D-BEA2-802DBD526383}" type="datetimeFigureOut">
               <a:rPr lang="de-AT" smtClean="0"/>
-              <a:t>26.06.2026</a:t>
+              <a:t>27.06.2026</a:t>
             </a:fld>
             <a:endParaRPr lang="de-AT"/>
           </a:p>
@@ -10725,7 +10863,7 @@
           <a:p>
             <a:fld id="{0A963F5A-521E-487D-BEA2-802DBD526383}" type="datetimeFigureOut">
               <a:rPr lang="de-AT" smtClean="0"/>
-              <a:t>26.06.2026</a:t>
+              <a:t>27.06.2026</a:t>
             </a:fld>
             <a:endParaRPr lang="de-AT"/>
           </a:p>
@@ -10867,7 +11005,7 @@
           <a:p>
             <a:fld id="{0A963F5A-521E-487D-BEA2-802DBD526383}" type="datetimeFigureOut">
               <a:rPr lang="de-AT" smtClean="0"/>
-              <a:t>26.06.2026</a:t>
+              <a:t>27.06.2026</a:t>
             </a:fld>
             <a:endParaRPr lang="de-AT"/>
           </a:p>
@@ -10980,7 +11118,7 @@
           <a:p>
             <a:fld id="{0A963F5A-521E-487D-BEA2-802DBD526383}" type="datetimeFigureOut">
               <a:rPr lang="de-AT" smtClean="0"/>
-              <a:t>26.06.2026</a:t>
+              <a:t>27.06.2026</a:t>
             </a:fld>
             <a:endParaRPr lang="de-AT"/>
           </a:p>
@@ -11293,7 +11431,7 @@
           <a:p>
             <a:fld id="{0A963F5A-521E-487D-BEA2-802DBD526383}" type="datetimeFigureOut">
               <a:rPr lang="de-AT" smtClean="0"/>
-              <a:t>26.06.2026</a:t>
+              <a:t>27.06.2026</a:t>
             </a:fld>
             <a:endParaRPr lang="de-AT"/>
           </a:p>
@@ -11582,7 +11720,7 @@
           <a:p>
             <a:fld id="{0A963F5A-521E-487D-BEA2-802DBD526383}" type="datetimeFigureOut">
               <a:rPr lang="de-AT" smtClean="0"/>
-              <a:t>26.06.2026</a:t>
+              <a:t>27.06.2026</a:t>
             </a:fld>
             <a:endParaRPr lang="de-AT"/>
           </a:p>
@@ -11825,7 +11963,7 @@
           <a:p>
             <a:fld id="{0A963F5A-521E-487D-BEA2-802DBD526383}" type="datetimeFigureOut">
               <a:rPr lang="de-AT" smtClean="0"/>
-              <a:t>26.06.2026</a:t>
+              <a:t>27.06.2026</a:t>
             </a:fld>
             <a:endParaRPr lang="de-AT"/>
           </a:p>
@@ -12491,6 +12629,358 @@
     <p:extLst>
       <p:ext uri="{BB962C8B-B14F-4D97-AF65-F5344CB8AC3E}">
         <p14:creationId xmlns:p14="http://schemas.microsoft.com/office/powerpoint/2010/main" val="3194339252"/>
+      </p:ext>
+    </p:extLst>
+  </p:cSld>
+  <p:clrMapOvr>
+    <a:masterClrMapping/>
+  </p:clrMapOvr>
+</p:sld>
+</file>
+
+<file path=ppt/slides/slide10.xml><?xml version="1.0" encoding="utf-8"?>
+<p:sld xmlns:a="http://schemas.openxmlformats.org/drawingml/2006/main" xmlns:r="http://schemas.openxmlformats.org/officeDocument/2006/relationships" xmlns:p="http://schemas.openxmlformats.org/presentationml/2006/main">
+  <p:cSld>
+    <p:spTree>
+      <p:nvGrpSpPr>
+        <p:cNvPr id="1" name=""/>
+        <p:cNvGrpSpPr/>
+        <p:nvPr/>
+      </p:nvGrpSpPr>
+      <p:grpSpPr>
+        <a:xfrm>
+          <a:off x="0" y="0"/>
+          <a:ext cx="0" cy="0"/>
+          <a:chOff x="0" y="0"/>
+          <a:chExt cx="0" cy="0"/>
+        </a:xfrm>
+      </p:grpSpPr>
+      <p:sp>
+        <p:nvSpPr>
+          <p:cNvPr id="2" name="Titel 1">
+            <a:extLst>
+              <a:ext uri="{FF2B5EF4-FFF2-40B4-BE49-F238E27FC236}">
+                <a16:creationId xmlns:a16="http://schemas.microsoft.com/office/drawing/2014/main" id="{822404E0-7640-7C59-DFAF-7ABB31DB7263}"/>
+              </a:ext>
+            </a:extLst>
+          </p:cNvPr>
+          <p:cNvSpPr>
+            <a:spLocks noGrp="1"/>
+          </p:cNvSpPr>
+          <p:nvPr>
+            <p:ph type="title"/>
+          </p:nvPr>
+        </p:nvSpPr>
+        <p:spPr/>
+        <p:txBody>
+          <a:bodyPr/>
+          <a:lstStyle/>
+          <a:p>
+            <a:r>
+              <a:rPr lang="de-AT" dirty="0"/>
+              <a:t>Testisolation und CI</a:t>
+            </a:r>
+          </a:p>
+        </p:txBody>
+      </p:sp>
+      <p:sp>
+        <p:nvSpPr>
+          <p:cNvPr id="3" name="Inhaltsplatzhalter 2">
+            <a:extLst>
+              <a:ext uri="{FF2B5EF4-FFF2-40B4-BE49-F238E27FC236}">
+                <a16:creationId xmlns:a16="http://schemas.microsoft.com/office/drawing/2014/main" id="{A5B2834C-0DFD-BB04-4FA8-E04275CCEE40}"/>
+              </a:ext>
+            </a:extLst>
+          </p:cNvPr>
+          <p:cNvSpPr>
+            <a:spLocks noGrp="1"/>
+          </p:cNvSpPr>
+          <p:nvPr>
+            <p:ph idx="1"/>
+          </p:nvPr>
+        </p:nvSpPr>
+        <p:spPr/>
+        <p:txBody>
+          <a:bodyPr/>
+          <a:lstStyle/>
+          <a:p>
+            <a:r>
+              <a:rPr lang="de-AT" dirty="0"/>
+              <a:t>Jeder Test verwendet neuen Docker-Container</a:t>
+            </a:r>
+          </a:p>
+          <a:p>
+            <a:endParaRPr lang="de-AT" dirty="0"/>
+          </a:p>
+          <a:p>
+            <a:r>
+              <a:rPr lang="de-AT" dirty="0"/>
+              <a:t>Keine </a:t>
+            </a:r>
+            <a:r>
+              <a:rPr lang="de-AT" dirty="0" err="1"/>
+              <a:t>Volumes</a:t>
+            </a:r>
+            <a:r>
+              <a:rPr lang="de-AT" dirty="0"/>
+              <a:t> verhindern ungewollte Datenpersistenz</a:t>
+            </a:r>
+          </a:p>
+          <a:p>
+            <a:endParaRPr lang="de-AT" dirty="0"/>
+          </a:p>
+          <a:p>
+            <a:r>
+              <a:rPr lang="de-AT" dirty="0"/>
+              <a:t>Eigenes </a:t>
+            </a:r>
+            <a:r>
+              <a:rPr lang="de-AT" dirty="0" err="1"/>
+              <a:t>Testscript</a:t>
+            </a:r>
+            <a:r>
+              <a:rPr lang="de-AT" dirty="0"/>
+              <a:t> führt alle Tests aus</a:t>
+            </a:r>
+          </a:p>
+        </p:txBody>
+      </p:sp>
+    </p:spTree>
+    <p:extLst>
+      <p:ext uri="{BB962C8B-B14F-4D97-AF65-F5344CB8AC3E}">
+        <p14:creationId xmlns:p14="http://schemas.microsoft.com/office/powerpoint/2010/main" val="2569992703"/>
+      </p:ext>
+    </p:extLst>
+  </p:cSld>
+  <p:clrMapOvr>
+    <a:masterClrMapping/>
+  </p:clrMapOvr>
+</p:sld>
+</file>
+
+<file path=ppt/slides/slide11.xml><?xml version="1.0" encoding="utf-8"?>
+<p:sld xmlns:a="http://schemas.openxmlformats.org/drawingml/2006/main" xmlns:r="http://schemas.openxmlformats.org/officeDocument/2006/relationships" xmlns:p="http://schemas.openxmlformats.org/presentationml/2006/main">
+  <p:cSld>
+    <p:spTree>
+      <p:nvGrpSpPr>
+        <p:cNvPr id="1" name=""/>
+        <p:cNvGrpSpPr/>
+        <p:nvPr/>
+      </p:nvGrpSpPr>
+      <p:grpSpPr>
+        <a:xfrm>
+          <a:off x="0" y="0"/>
+          <a:ext cx="0" cy="0"/>
+          <a:chOff x="0" y="0"/>
+          <a:chExt cx="0" cy="0"/>
+        </a:xfrm>
+      </p:grpSpPr>
+      <p:sp>
+        <p:nvSpPr>
+          <p:cNvPr id="2" name="Titel 1">
+            <a:extLst>
+              <a:ext uri="{FF2B5EF4-FFF2-40B4-BE49-F238E27FC236}">
+                <a16:creationId xmlns:a16="http://schemas.microsoft.com/office/drawing/2014/main" id="{5F1A5C91-06C3-FB2C-2233-6C5D4CE2E350}"/>
+              </a:ext>
+            </a:extLst>
+          </p:cNvPr>
+          <p:cNvSpPr>
+            <a:spLocks noGrp="1"/>
+          </p:cNvSpPr>
+          <p:nvPr>
+            <p:ph type="title"/>
+          </p:nvPr>
+        </p:nvSpPr>
+        <p:spPr/>
+        <p:txBody>
+          <a:bodyPr/>
+          <a:lstStyle/>
+          <a:p>
+            <a:r>
+              <a:rPr lang="de-AT" dirty="0"/>
+              <a:t>K6 Threshold-Tests (</a:t>
+            </a:r>
+            <a:r>
+              <a:rPr lang="de-AT" dirty="0" err="1"/>
+              <a:t>GetCategory</a:t>
+            </a:r>
+            <a:r>
+              <a:rPr lang="de-AT" dirty="0"/>
+              <a:t>)</a:t>
+            </a:r>
+          </a:p>
+        </p:txBody>
+      </p:sp>
+      <p:sp>
+        <p:nvSpPr>
+          <p:cNvPr id="3" name="Inhaltsplatzhalter 2">
+            <a:extLst>
+              <a:ext uri="{FF2B5EF4-FFF2-40B4-BE49-F238E27FC236}">
+                <a16:creationId xmlns:a16="http://schemas.microsoft.com/office/drawing/2014/main" id="{EE5C2830-2E75-E945-64AE-BE4CC7F615B1}"/>
+              </a:ext>
+            </a:extLst>
+          </p:cNvPr>
+          <p:cNvSpPr>
+            <a:spLocks noGrp="1"/>
+          </p:cNvSpPr>
+          <p:nvPr>
+            <p:ph idx="1"/>
+          </p:nvPr>
+        </p:nvSpPr>
+        <p:spPr/>
+        <p:txBody>
+          <a:bodyPr/>
+          <a:lstStyle/>
+          <a:p>
+            <a:endParaRPr lang="de-AT"/>
+          </a:p>
+        </p:txBody>
+      </p:sp>
+      <p:pic>
+        <p:nvPicPr>
+          <p:cNvPr id="4" name="Grafik 3">
+            <a:extLst>
+              <a:ext uri="{FF2B5EF4-FFF2-40B4-BE49-F238E27FC236}">
+                <a16:creationId xmlns:a16="http://schemas.microsoft.com/office/drawing/2014/main" id="{A04F5B7D-BF20-EEE4-87F4-ABFAE324C4E5}"/>
+              </a:ext>
+            </a:extLst>
+          </p:cNvPr>
+          <p:cNvPicPr>
+            <a:picLocks noChangeAspect="1"/>
+          </p:cNvPicPr>
+          <p:nvPr/>
+        </p:nvPicPr>
+        <p:blipFill>
+          <a:blip r:embed="rId2"/>
+          <a:stretch>
+            <a:fillRect/>
+          </a:stretch>
+        </p:blipFill>
+        <p:spPr>
+          <a:xfrm>
+            <a:off x="0" y="1747066"/>
+            <a:ext cx="12192000" cy="4796609"/>
+          </a:xfrm>
+          <a:prstGeom prst="rect">
+            <a:avLst/>
+          </a:prstGeom>
+        </p:spPr>
+      </p:pic>
+    </p:spTree>
+    <p:extLst>
+      <p:ext uri="{BB962C8B-B14F-4D97-AF65-F5344CB8AC3E}">
+        <p14:creationId xmlns:p14="http://schemas.microsoft.com/office/powerpoint/2010/main" val="1465121941"/>
+      </p:ext>
+    </p:extLst>
+  </p:cSld>
+  <p:clrMapOvr>
+    <a:masterClrMapping/>
+  </p:clrMapOvr>
+</p:sld>
+</file>
+
+<file path=ppt/slides/slide12.xml><?xml version="1.0" encoding="utf-8"?>
+<p:sld xmlns:a="http://schemas.openxmlformats.org/drawingml/2006/main" xmlns:r="http://schemas.openxmlformats.org/officeDocument/2006/relationships" xmlns:p="http://schemas.openxmlformats.org/presentationml/2006/main">
+  <p:cSld>
+    <p:spTree>
+      <p:nvGrpSpPr>
+        <p:cNvPr id="1" name="">
+          <a:extLst>
+            <a:ext uri="{FF2B5EF4-FFF2-40B4-BE49-F238E27FC236}">
+              <a16:creationId xmlns:a16="http://schemas.microsoft.com/office/drawing/2014/main" id="{089A2C73-60B8-2379-3775-1A69C2EFC52B}"/>
+            </a:ext>
+          </a:extLst>
+        </p:cNvPr>
+        <p:cNvGrpSpPr/>
+        <p:nvPr/>
+      </p:nvGrpSpPr>
+      <p:grpSpPr>
+        <a:xfrm>
+          <a:off x="0" y="0"/>
+          <a:ext cx="0" cy="0"/>
+          <a:chOff x="0" y="0"/>
+          <a:chExt cx="0" cy="0"/>
+        </a:xfrm>
+      </p:grpSpPr>
+      <p:sp>
+        <p:nvSpPr>
+          <p:cNvPr id="2" name="Titel 1">
+            <a:extLst>
+              <a:ext uri="{FF2B5EF4-FFF2-40B4-BE49-F238E27FC236}">
+                <a16:creationId xmlns:a16="http://schemas.microsoft.com/office/drawing/2014/main" id="{73412F77-1982-D332-2CE1-681EE89D99D4}"/>
+              </a:ext>
+            </a:extLst>
+          </p:cNvPr>
+          <p:cNvSpPr>
+            <a:spLocks noGrp="1"/>
+          </p:cNvSpPr>
+          <p:nvPr>
+            <p:ph type="title"/>
+          </p:nvPr>
+        </p:nvSpPr>
+        <p:spPr/>
+        <p:txBody>
+          <a:bodyPr/>
+          <a:lstStyle/>
+          <a:p>
+            <a:r>
+              <a:rPr lang="de-AT" dirty="0"/>
+              <a:t>K6 Threshold-Tests (Create </a:t>
+            </a:r>
+            <a:r>
+              <a:rPr lang="de-AT" dirty="0" err="1"/>
+              <a:t>Category</a:t>
+            </a:r>
+            <a:r>
+              <a:rPr lang="de-AT"/>
+              <a:t>)</a:t>
+            </a:r>
+            <a:endParaRPr lang="de-AT" dirty="0"/>
+          </a:p>
+        </p:txBody>
+      </p:sp>
+      <p:pic>
+        <p:nvPicPr>
+          <p:cNvPr id="8" name="Inhaltsplatzhalter 7">
+            <a:extLst>
+              <a:ext uri="{FF2B5EF4-FFF2-40B4-BE49-F238E27FC236}">
+                <a16:creationId xmlns:a16="http://schemas.microsoft.com/office/drawing/2014/main" id="{3B744437-88BB-0298-FB3B-86E85DCFE67C}"/>
+              </a:ext>
+            </a:extLst>
+          </p:cNvPr>
+          <p:cNvPicPr>
+            <a:picLocks noGrp="1" noChangeAspect="1"/>
+          </p:cNvPicPr>
+          <p:nvPr>
+            <p:ph idx="1"/>
+          </p:nvPr>
+        </p:nvPicPr>
+        <p:blipFill>
+          <a:blip r:embed="rId2">
+            <a:extLst>
+              <a:ext uri="{28A0092B-C50C-407E-A947-70E740481C1C}">
+                <a14:useLocalDpi xmlns:a14="http://schemas.microsoft.com/office/drawing/2010/main" val="0"/>
+              </a:ext>
+            </a:extLst>
+          </a:blip>
+          <a:stretch>
+            <a:fillRect/>
+          </a:stretch>
+        </p:blipFill>
+        <p:spPr>
+          <a:xfrm>
+            <a:off x="0" y="1737753"/>
+            <a:ext cx="12192000" cy="4828071"/>
+          </a:xfrm>
+          <a:prstGeom prst="rect">
+            <a:avLst/>
+          </a:prstGeom>
+        </p:spPr>
+      </p:pic>
+    </p:spTree>
+    <p:extLst>
+      <p:ext uri="{BB962C8B-B14F-4D97-AF65-F5344CB8AC3E}">
+        <p14:creationId xmlns:p14="http://schemas.microsoft.com/office/powerpoint/2010/main" val="1055078836"/>
       </p:ext>
     </p:extLst>
   </p:cSld>
@@ -13927,6 +14417,15 @@
               <a:t>, Tests mit Hilfe von UI)</a:t>
             </a:r>
           </a:p>
+          <a:p>
+            <a:endParaRPr lang="de-AT" dirty="0"/>
+          </a:p>
+          <a:p>
+            <a:r>
+              <a:rPr lang="de-AT" dirty="0"/>
+              <a:t>Load Tests(k6, Realistischen Anfrageraten, Threshold)</a:t>
+            </a:r>
+          </a:p>
         </p:txBody>
       </p:sp>
     </p:spTree>

</xml_diff>